<commit_message>
feat: aula 10092026 - dashboard de usuarios com bootstrap e api
</commit_message>
<xml_diff>
--- a/10092026/Apresentação principal.pptx
+++ b/10092026/Apresentação principal.pptx
@@ -2913,7 +2913,7 @@
                 <a:effectLst/>
                 <a:latin typeface="+mj-lt"/>
               </a:rPr>
-              <a:t>“O entendimento do passado nos oferece um parâmetro para projetarmos o futuro, mas é o presente que revela a real situação do nosso progresso. Por isso, tenha total acuidade ao seu hoje.”</a:t>
+              <a:t>“O entendimento do passado nos oferece um parâmetro para projetarmos o futuro, mas é o presente que revela a real situação do nosso progresso. Por isso, tenha acuidade ao seu hoje.”</a:t>
             </a:r>
             <a:r>
               <a:rPr lang="pt-BR" sz="2400" i="1" dirty="0">
@@ -3048,7 +3048,7 @@
                 <a:latin typeface="Times New Roman" panose="02020603050405020304" pitchFamily="18" charset="0"/>
                 <a:cs typeface="Times New Roman" panose="02020603050405020304" pitchFamily="18" charset="0"/>
               </a:rPr>
-              <a:t>Todas as APIs REST modernas que consumiremos na aula de hoje (</a:t>
+              <a:t>Todas as APIs REST (</a:t>
             </a:r>
             <a:r>
               <a:rPr lang="pt-BR" sz="2400" dirty="0" err="1">
@@ -4246,13 +4246,13 @@
           <p:nvPr>
             <p:extLst>
               <p:ext uri="{D42A27DB-BD31-4B8C-83A1-F6EECF244321}">
-                <p14:modId xmlns:p14="http://schemas.microsoft.com/office/powerpoint/2010/main" val="2253491092"/>
+                <p14:modId xmlns:p14="http://schemas.microsoft.com/office/powerpoint/2010/main" val="574691083"/>
               </p:ext>
             </p:extLst>
           </p:nvPr>
         </p:nvGraphicFramePr>
         <p:xfrm>
-          <a:off x="116457" y="2876026"/>
+          <a:off x="107831" y="2901904"/>
           <a:ext cx="10515600" cy="3251200"/>
         </p:xfrm>
         <a:graphic>
@@ -5188,8 +5188,8 @@
         </p:nvSpPr>
         <p:spPr bwMode="auto">
           <a:xfrm>
-            <a:off x="10740" y="550372"/>
-            <a:ext cx="12181259" cy="2477601"/>
+            <a:off x="10740" y="549682"/>
+            <a:ext cx="12181259" cy="2323713"/>
           </a:xfrm>
           <a:prstGeom prst="rect">
             <a:avLst/>
@@ -5254,7 +5254,7 @@
               <a:tabLst/>
             </a:pPr>
             <a:r>
-              <a:rPr kumimoji="0" lang="pt-BR" altLang="pt-BR" sz="2000" b="1" i="0" u="none" strike="noStrike" cap="none" normalizeH="0" baseline="0" dirty="0">
+              <a:rPr kumimoji="0" lang="pt-BR" altLang="pt-BR" sz="2400" b="1" i="0" u="none" strike="noStrike" cap="none" normalizeH="0" baseline="0" dirty="0">
                 <a:ln>
                   <a:noFill/>
                 </a:ln>
@@ -5268,7 +5268,7 @@
               <a:t>Resumo dos outros protocolos listados na imagem para referência de aula:</a:t>
             </a:r>
             <a:br>
-              <a:rPr kumimoji="0" lang="pt-BR" altLang="pt-BR" sz="2000" b="1" i="0" u="none" strike="noStrike" cap="none" normalizeH="0" baseline="0" dirty="0">
+              <a:rPr kumimoji="0" lang="pt-BR" altLang="pt-BR" sz="2400" b="1" i="0" u="none" strike="noStrike" cap="none" normalizeH="0" baseline="0" dirty="0">
                 <a:ln>
                   <a:noFill/>
                 </a:ln>
@@ -5280,7 +5280,7 @@
                 <a:cs typeface="Times New Roman" panose="02020603050405020304" pitchFamily="18" charset="0"/>
               </a:rPr>
             </a:br>
-            <a:endParaRPr kumimoji="0" lang="pt-BR" altLang="pt-BR" sz="2000" b="0" i="0" u="none" strike="noStrike" cap="none" normalizeH="0" baseline="0" dirty="0">
+            <a:endParaRPr kumimoji="0" lang="pt-BR" altLang="pt-BR" sz="2400" b="0" i="0" u="none" strike="noStrike" cap="none" normalizeH="0" baseline="0" dirty="0">
               <a:ln>
                 <a:noFill/>
               </a:ln>
@@ -5541,34 +5541,6 @@
               </a:rPr>
               <a:t> Utiliza conexões persistentes bidirecionais e protocolos de transporte em tempo real, sem se limitar ao modelo tradicional de requisição/resposta do HTTP.</a:t>
             </a:r>
-          </a:p>
-          <a:p>
-            <a:pPr marL="0" marR="0" lvl="0" indent="0" algn="l" defTabSz="914400" rtl="0" eaLnBrk="0" fontAlgn="base" latinLnBrk="0" hangingPunct="0">
-              <a:lnSpc>
-                <a:spcPct val="100000"/>
-              </a:lnSpc>
-              <a:spcBef>
-                <a:spcPct val="0"/>
-              </a:spcBef>
-              <a:spcAft>
-                <a:spcPct val="0"/>
-              </a:spcAft>
-              <a:buClrTx/>
-              <a:buSzTx/>
-              <a:buFontTx/>
-              <a:buNone/>
-              <a:tabLst/>
-            </a:pPr>
-            <a:endParaRPr kumimoji="0" lang="pt-BR" altLang="pt-BR" sz="1800" b="0" i="0" u="none" strike="noStrike" cap="none" normalizeH="0" baseline="0" dirty="0">
-              <a:ln>
-                <a:noFill/>
-              </a:ln>
-              <a:solidFill>
-                <a:schemeClr val="tx1"/>
-              </a:solidFill>
-              <a:effectLst/>
-              <a:latin typeface="Arial" panose="020B0604020202020204" pitchFamily="34" charset="0"/>
-            </a:endParaRPr>
           </a:p>
         </p:txBody>
       </p:sp>
@@ -6814,7 +6786,7 @@
                 <a:latin typeface="Times New Roman" panose="02020603050405020304" pitchFamily="18" charset="0"/>
                 <a:cs typeface="Times New Roman" panose="02020603050405020304" pitchFamily="18" charset="0"/>
               </a:rPr>
-              <a:t>No fluxo real do Checkpoint 2, o método </a:t>
+              <a:t>O método </a:t>
             </a:r>
             <a:r>
               <a:rPr lang="pt-BR" sz="2000" dirty="0" err="1">

</xml_diff>